<commit_message>
PRX-0012: decks sectoriales PRAXIA (maestro + 6 sectores) y mensajes
Contenido de MKT-02 con cifras A1-A21 aprobadas por RES-01; .pptx y .pdf
renderizados con el deck-builder de DSN-01. Canal de contacto pendiente.

Co-Authored-By: Claude Opus 5.5 <noreply@anthropic.com>
Claude-Session: https://claude.ai/code/session_01D3GW9GwhM4z7Kb2w4Upnzq
</commit_message>
<xml_diff>
--- a/praxia/equipos/E2-revenue/2026-10-09-PRX-0012-prospeccion-sectorial/00-maestro/deck-praxia-maestro.pptx
+++ b/praxia/equipos/E2-revenue/2026-10-09-PRX-0012-prospeccion-sectorial/00-maestro/deck-praxia-maestro.pptx
@@ -1041,7 +1041,10 @@
           <a:p>
             <a:r>
               <a:rPr lang="en-US" dirty="0"/>
-              <a:t/>
+              <a:t>Fuentes de esta lámina (texto completo y enlace):
+• Solo ~5% de las organizaciones obtiene ganancias financieras sustanciales de la IA. Fuente: BCG, 2026. https://www.bcg.com/publications/2026/ai-transformation-is-a-workforce-transformation
+• En la experiencia de BCG, ~70% del valor de la IA depende de repensar el componente humano; 20%, de la tecnología; 10%, de los algoritmos. Fuente: BCG, 2026. https://www.bcg.com/publications/2026/ai-transformation-is-a-workforce-transformation
+• En México, 56% de las empresas aún no identifica con claridad el valor de negocio de la IA, y solo 27% tiene una estrategia de IA bien definida. Fuente: KPMG México, 2025. https://kpmg.com/mx/es/sala-de-prensa/comunicados-de-prensa/2025/10/cp-empresas-en-mexico-y-centroamerica-apuestan-por-la-ia.html</a:t>
             </a:r>
             <a:endParaRPr lang="en-US" dirty="0"/>
           </a:p>
@@ -2722,7 +2725,7 @@
         </p:nvSpPr>
         <p:spPr>
           <a:xfrm>
-            <a:off x="3429000" y="4919472"/>
+            <a:off x="3429000" y="4306824"/>
             <a:ext cx="73152" cy="73152"/>
           </a:xfrm>
           <a:prstGeom prst="rect">
@@ -2742,7 +2745,7 @@
         </p:nvSpPr>
         <p:spPr>
           <a:xfrm>
-            <a:off x="3630168" y="4846320"/>
+            <a:off x="3630168" y="4233672"/>
             <a:ext cx="3741268" cy="502920"/>
           </a:xfrm>
           <a:prstGeom prst="rect">
@@ -2784,7 +2787,7 @@
         </p:nvSpPr>
         <p:spPr>
           <a:xfrm>
-            <a:off x="7673188" y="4919472"/>
+            <a:off x="7673188" y="4306824"/>
             <a:ext cx="73152" cy="73152"/>
           </a:xfrm>
           <a:prstGeom prst="rect">
@@ -2804,7 +2807,7 @@
         </p:nvSpPr>
         <p:spPr>
           <a:xfrm>
-            <a:off x="7874356" y="4846320"/>
+            <a:off x="7874356" y="4233672"/>
             <a:ext cx="3741268" cy="502920"/>
           </a:xfrm>
           <a:prstGeom prst="rect">
@@ -2846,7 +2849,7 @@
         </p:nvSpPr>
         <p:spPr>
           <a:xfrm>
-            <a:off x="3429000" y="5486400"/>
+            <a:off x="3429000" y="4873752"/>
             <a:ext cx="73152" cy="73152"/>
           </a:xfrm>
           <a:prstGeom prst="rect">
@@ -2866,7 +2869,7 @@
         </p:nvSpPr>
         <p:spPr>
           <a:xfrm>
-            <a:off x="3630168" y="5413248"/>
+            <a:off x="3630168" y="4800600"/>
             <a:ext cx="3741268" cy="502920"/>
           </a:xfrm>
           <a:prstGeom prst="rect">
@@ -2908,7 +2911,7 @@
         </p:nvSpPr>
         <p:spPr>
           <a:xfrm>
-            <a:off x="7673188" y="5486400"/>
+            <a:off x="7673188" y="4873752"/>
             <a:ext cx="73152" cy="73152"/>
           </a:xfrm>
           <a:prstGeom prst="rect">
@@ -2928,7 +2931,7 @@
         </p:nvSpPr>
         <p:spPr>
           <a:xfrm>
-            <a:off x="7874356" y="5413248"/>
+            <a:off x="7874356" y="4800600"/>
             <a:ext cx="3741268" cy="502920"/>
           </a:xfrm>
           <a:prstGeom prst="rect">
@@ -3190,8 +3193,8 @@
         </p:nvSpPr>
         <p:spPr>
           <a:xfrm>
-            <a:off x="548640" y="960120"/>
-            <a:ext cx="9601200" cy="1417320"/>
+            <a:off x="548640" y="1335024"/>
+            <a:ext cx="9601200" cy="978408"/>
           </a:xfrm>
           <a:prstGeom prst="rect">
             <a:avLst/>
@@ -3266,8 +3269,8 @@
         </p:nvSpPr>
         <p:spPr>
           <a:xfrm>
-            <a:off x="548640" y="2514600"/>
-            <a:ext cx="7863840" cy="914400"/>
+            <a:off x="548640" y="2404872"/>
+            <a:ext cx="7863840" cy="1024128"/>
           </a:xfrm>
           <a:prstGeom prst="rect">
             <a:avLst/>
@@ -4221,7 +4224,7 @@
         <p:spPr>
           <a:xfrm>
             <a:off x="548640" y="5394960"/>
-            <a:ext cx="3383280" cy="566928"/>
+            <a:ext cx="3383280" cy="932688"/>
           </a:xfrm>
           <a:prstGeom prst="rect">
             <a:avLst/>
@@ -4318,7 +4321,7 @@
               <a:buNone/>
             </a:pPr>
             <a:r>
-              <a:rPr lang="en-US" sz="1050" b="1" spc="100" kern="0" dirty="0">
+              <a:rPr lang="en-US" sz="1050" b="1" dirty="0">
                 <a:solidFill>
                   <a:srgbClr val="E9663C"/>
                 </a:solidFill>
@@ -4913,8 +4916,8 @@
         </p:nvSpPr>
         <p:spPr>
           <a:xfrm>
-            <a:off x="548640" y="1417320"/>
-            <a:ext cx="9966960" cy="3429000"/>
+            <a:off x="548640" y="1733804"/>
+            <a:ext cx="9966960" cy="2540000"/>
           </a:xfrm>
           <a:prstGeom prst="rect">
             <a:avLst/>
@@ -4955,8 +4958,8 @@
         </p:nvSpPr>
         <p:spPr>
           <a:xfrm>
-            <a:off x="548640" y="5029200"/>
-            <a:ext cx="7863840" cy="868680"/>
+            <a:off x="548640" y="4502404"/>
+            <a:ext cx="7863840" cy="758952"/>
           </a:xfrm>
           <a:prstGeom prst="rect">
             <a:avLst/>
@@ -5218,7 +5221,7 @@
         <p:spPr>
           <a:xfrm>
             <a:off x="548640" y="914400"/>
-            <a:ext cx="5394960" cy="1828800"/>
+            <a:ext cx="5394960" cy="801624"/>
           </a:xfrm>
           <a:prstGeom prst="rect">
             <a:avLst/>
@@ -5293,8 +5296,8 @@
         </p:nvSpPr>
         <p:spPr>
           <a:xfrm>
-            <a:off x="548640" y="2971800"/>
-            <a:ext cx="5120640" cy="2377440"/>
+            <a:off x="548640" y="2377440"/>
+            <a:ext cx="5120640" cy="3474720"/>
           </a:xfrm>
           <a:prstGeom prst="rect">
             <a:avLst/>
@@ -5887,7 +5890,7 @@
       </p:sp>
       <p:sp>
         <p:nvSpPr>
-          <p:cNvPr id="7" name="Text 5"/>
+          <p:cNvPr id="8" name="Text 5"/>
           <p:cNvSpPr txBox="1"/>
           <p:nvPr/>
         </p:nvSpPr>
@@ -5929,7 +5932,7 @@
       </p:sp>
       <p:sp>
         <p:nvSpPr>
-          <p:cNvPr id="8" name="Shape 6"/>
+          <p:cNvPr id="9" name="Shape 6"/>
           <p:cNvSpPr/>
           <p:nvPr/>
         </p:nvSpPr>
@@ -5949,7 +5952,7 @@
       </p:sp>
       <p:sp>
         <p:nvSpPr>
-          <p:cNvPr id="9" name="Shape 7"/>
+          <p:cNvPr id="10" name="Shape 7"/>
           <p:cNvSpPr/>
           <p:nvPr/>
         </p:nvSpPr>
@@ -5972,7 +5975,7 @@
       </p:sp>
       <p:sp>
         <p:nvSpPr>
-          <p:cNvPr id="10" name="Shape 8"/>
+          <p:cNvPr id="11" name="Shape 8"/>
           <p:cNvSpPr/>
           <p:nvPr/>
         </p:nvSpPr>
@@ -5995,7 +5998,7 @@
       </p:sp>
       <p:sp>
         <p:nvSpPr>
-          <p:cNvPr id="11" name="Shape 9"/>
+          <p:cNvPr id="12" name="Shape 9"/>
           <p:cNvSpPr/>
           <p:nvPr/>
         </p:nvSpPr>
@@ -6018,7 +6021,7 @@
       </p:sp>
       <p:sp>
         <p:nvSpPr>
-          <p:cNvPr id="12" name="Shape 10"/>
+          <p:cNvPr id="13" name="Shape 10"/>
           <p:cNvSpPr/>
           <p:nvPr/>
         </p:nvSpPr>
@@ -6041,7 +6044,7 @@
       </p:sp>
       <p:sp>
         <p:nvSpPr>
-          <p:cNvPr id="13" name="Shape 11"/>
+          <p:cNvPr id="14" name="Shape 11"/>
           <p:cNvSpPr/>
           <p:nvPr/>
         </p:nvSpPr>
@@ -6064,7 +6067,7 @@
       </p:sp>
       <p:sp>
         <p:nvSpPr>
-          <p:cNvPr id="14" name="Shape 12"/>
+          <p:cNvPr id="15" name="Shape 12"/>
           <p:cNvSpPr/>
           <p:nvPr/>
         </p:nvSpPr>
@@ -6087,7 +6090,7 @@
       </p:sp>
       <p:sp>
         <p:nvSpPr>
-          <p:cNvPr id="15" name="Shape 13"/>
+          <p:cNvPr id="16" name="Shape 13"/>
           <p:cNvSpPr/>
           <p:nvPr/>
         </p:nvSpPr>
@@ -6110,7 +6113,7 @@
       </p:sp>
       <p:sp>
         <p:nvSpPr>
-          <p:cNvPr id="16" name="Shape 14"/>
+          <p:cNvPr id="17" name="Shape 14"/>
           <p:cNvSpPr/>
           <p:nvPr/>
         </p:nvSpPr>
@@ -6133,36 +6136,14 @@
       </p:sp>
       <p:sp>
         <p:nvSpPr>
-          <p:cNvPr id="17" name="Shape 15"/>
-          <p:cNvSpPr/>
-          <p:nvPr/>
-        </p:nvSpPr>
-        <p:spPr>
-          <a:xfrm>
-            <a:off x="822960" y="2697480"/>
-            <a:ext cx="2966618" cy="914400"/>
-          </a:xfrm>
-          <a:prstGeom prst="rect">
-            <a:avLst/>
-          </a:prstGeom>
-          <a:ln w="9525">
-            <a:solidFill>
-              <a:srgbClr val="E9663C"/>
-            </a:solidFill>
-            <a:prstDash val="solid"/>
-          </a:ln>
-        </p:spPr>
-      </p:sp>
-      <p:sp>
-        <p:nvSpPr>
-          <p:cNvPr id="18" name="Text 16"/>
-          <p:cNvSpPr txBox="1"/>
-          <p:nvPr/>
-        </p:nvSpPr>
-        <p:spPr>
-          <a:xfrm>
-            <a:off x="932688" y="2761488"/>
-            <a:ext cx="2747162" cy="786384"/>
+          <p:cNvPr id="18" name="Text 15"/>
+          <p:cNvSpPr txBox="1"/>
+          <p:nvPr/>
+        </p:nvSpPr>
+        <p:spPr>
+          <a:xfrm>
+            <a:off x="822960" y="2606040"/>
+            <a:ext cx="3058058" cy="1051560"/>
           </a:xfrm>
           <a:prstGeom prst="rect">
             <a:avLst/>
@@ -6178,29 +6159,356 @@
               <a:buNone/>
             </a:pPr>
             <a:r>
-              <a:rPr lang="en-US" sz="1200" b="1" spc="100" kern="0" dirty="0">
-                <a:solidFill>
-                  <a:srgbClr val="E9663C"/>
+              <a:rPr lang="en-US" sz="6400" b="1" dirty="0">
+                <a:solidFill>
+                  <a:srgbClr val="F5F2EC"/>
+                </a:solidFill>
+                <a:latin typeface="Space Grotesk" pitchFamily="34" charset="0"/>
+                <a:ea typeface="Space Grotesk" pitchFamily="34" charset="-122"/>
+                <a:cs typeface="Space Grotesk" pitchFamily="34" charset="-120"/>
+              </a:rPr>
+              <a:t>~5%</a:t>
+            </a:r>
+            <a:endParaRPr lang="en-US" sz="6400" dirty="0"/>
+          </a:p>
+        </p:txBody>
+      </p:sp>
+      <p:sp>
+        <p:nvSpPr>
+          <p:cNvPr id="19" name="Text 16"/>
+          <p:cNvSpPr txBox="1"/>
+          <p:nvPr/>
+        </p:nvSpPr>
+        <p:spPr>
+          <a:xfrm>
+            <a:off x="822960" y="3840480"/>
+            <a:ext cx="2966618" cy="1234440"/>
+          </a:xfrm>
+          <a:prstGeom prst="rect">
+            <a:avLst/>
+          </a:prstGeom>
+          <a:noFill/>
+          <a:ln/>
+        </p:spPr>
+        <p:txBody>
+          <a:bodyPr wrap="square" lIns="0" tIns="0" rIns="0" bIns="0" rtlCol="0" anchor="t"/>
+          <a:lstStyle/>
+          <a:p>
+            <a:pPr indent="0" marL="0">
+              <a:lnSpc>
+                <a:spcPct val="115000"/>
+              </a:lnSpc>
+              <a:buNone/>
+            </a:pPr>
+            <a:r>
+              <a:rPr lang="en-US" sz="1500" dirty="0">
+                <a:solidFill>
+                  <a:srgbClr val="F5F2EC"/>
+                </a:solidFill>
+                <a:latin typeface="Inter" pitchFamily="34" charset="0"/>
+                <a:ea typeface="Inter" pitchFamily="34" charset="-122"/>
+                <a:cs typeface="Inter" pitchFamily="34" charset="-120"/>
+              </a:rPr>
+              <a:t>de las organizaciones obtiene ganancias financieras sustanciales de la IA.</a:t>
+            </a:r>
+            <a:endParaRPr lang="en-US" sz="1500" dirty="0"/>
+          </a:p>
+        </p:txBody>
+      </p:sp>
+      <p:sp>
+        <p:nvSpPr>
+          <p:cNvPr id="20" name="Text 17"/>
+          <p:cNvSpPr txBox="1"/>
+          <p:nvPr/>
+        </p:nvSpPr>
+        <p:spPr>
+          <a:xfrm>
+            <a:off x="822960" y="5166360"/>
+            <a:ext cx="2966618" cy="502920"/>
+          </a:xfrm>
+          <a:prstGeom prst="rect">
+            <a:avLst/>
+          </a:prstGeom>
+          <a:noFill/>
+          <a:ln/>
+        </p:spPr>
+        <p:txBody>
+          <a:bodyPr wrap="square" lIns="0" tIns="0" rIns="0" bIns="0" rtlCol="0" anchor="b"/>
+          <a:lstStyle/>
+          <a:p>
+            <a:pPr indent="0" marL="0">
+              <a:lnSpc>
+                <a:spcPct val="110000"/>
+              </a:lnSpc>
+              <a:buNone/>
+            </a:pPr>
+            <a:r>
+              <a:rPr lang="en-US" sz="800" dirty="0">
+                <a:solidFill>
+                  <a:srgbClr val="A7AAB5"/>
                 </a:solidFill>
                 <a:latin typeface="Space Mono" pitchFamily="34" charset="0"/>
                 <a:ea typeface="Space Mono" pitchFamily="34" charset="-122"/>
                 <a:cs typeface="Space Mono" pitchFamily="34" charset="-120"/>
               </a:rPr>
-              <a:t>[CIFRA PENDIENTE RES-01]</a:t>
-            </a:r>
-            <a:endParaRPr lang="en-US" sz="1200" dirty="0"/>
-          </a:p>
-        </p:txBody>
-      </p:sp>
-      <p:sp>
-        <p:nvSpPr>
-          <p:cNvPr id="19" name="Text 17"/>
-          <p:cNvSpPr txBox="1"/>
-          <p:nvPr/>
-        </p:nvSpPr>
-        <p:spPr>
-          <a:xfrm>
-            <a:off x="822960" y="3840480"/>
+              <a:t>FUENTE · BCG, 2026 · AI Transformation Is a Workforce Transformation</a:t>
+            </a:r>
+            <a:endParaRPr lang="en-US" sz="800" dirty="0"/>
+          </a:p>
+        </p:txBody>
+      </p:sp>
+      <p:sp>
+        <p:nvSpPr>
+          <p:cNvPr id="21" name="Shape 18"/>
+          <p:cNvSpPr/>
+          <p:nvPr/>
+        </p:nvSpPr>
+        <p:spPr>
+          <a:xfrm>
+            <a:off x="4338218" y="2377440"/>
+            <a:ext cx="3515258" cy="3429000"/>
+          </a:xfrm>
+          <a:prstGeom prst="rect">
+            <a:avLst/>
+          </a:prstGeom>
+          <a:solidFill>
+            <a:srgbClr val="15161D"/>
+          </a:solidFill>
+          <a:ln/>
+        </p:spPr>
+      </p:sp>
+      <p:sp>
+        <p:nvSpPr>
+          <p:cNvPr id="22" name="Shape 19"/>
+          <p:cNvSpPr/>
+          <p:nvPr/>
+        </p:nvSpPr>
+        <p:spPr>
+          <a:xfrm>
+            <a:off x="4338218" y="2377440"/>
+            <a:ext cx="146304" cy="0"/>
+          </a:xfrm>
+          <a:prstGeom prst="line">
+            <a:avLst/>
+          </a:prstGeom>
+          <a:noFill/>
+          <a:ln w="12700">
+            <a:solidFill>
+              <a:srgbClr val="2A2B33"/>
+            </a:solidFill>
+            <a:prstDash val="solid"/>
+          </a:ln>
+        </p:spPr>
+      </p:sp>
+      <p:sp>
+        <p:nvSpPr>
+          <p:cNvPr id="23" name="Shape 20"/>
+          <p:cNvSpPr/>
+          <p:nvPr/>
+        </p:nvSpPr>
+        <p:spPr>
+          <a:xfrm>
+            <a:off x="4338218" y="2377440"/>
+            <a:ext cx="0" cy="146304"/>
+          </a:xfrm>
+          <a:prstGeom prst="line">
+            <a:avLst/>
+          </a:prstGeom>
+          <a:noFill/>
+          <a:ln w="12700">
+            <a:solidFill>
+              <a:srgbClr val="2A2B33"/>
+            </a:solidFill>
+            <a:prstDash val="solid"/>
+          </a:ln>
+        </p:spPr>
+      </p:sp>
+      <p:sp>
+        <p:nvSpPr>
+          <p:cNvPr id="24" name="Shape 21"/>
+          <p:cNvSpPr/>
+          <p:nvPr/>
+        </p:nvSpPr>
+        <p:spPr>
+          <a:xfrm>
+            <a:off x="7707173" y="2377440"/>
+            <a:ext cx="146304" cy="0"/>
+          </a:xfrm>
+          <a:prstGeom prst="line">
+            <a:avLst/>
+          </a:prstGeom>
+          <a:noFill/>
+          <a:ln w="12700">
+            <a:solidFill>
+              <a:srgbClr val="2A2B33"/>
+            </a:solidFill>
+            <a:prstDash val="solid"/>
+          </a:ln>
+        </p:spPr>
+      </p:sp>
+      <p:sp>
+        <p:nvSpPr>
+          <p:cNvPr id="25" name="Shape 22"/>
+          <p:cNvSpPr/>
+          <p:nvPr/>
+        </p:nvSpPr>
+        <p:spPr>
+          <a:xfrm>
+            <a:off x="7853477" y="2377440"/>
+            <a:ext cx="0" cy="146304"/>
+          </a:xfrm>
+          <a:prstGeom prst="line">
+            <a:avLst/>
+          </a:prstGeom>
+          <a:noFill/>
+          <a:ln w="12700">
+            <a:solidFill>
+              <a:srgbClr val="2A2B33"/>
+            </a:solidFill>
+            <a:prstDash val="solid"/>
+          </a:ln>
+        </p:spPr>
+      </p:sp>
+      <p:sp>
+        <p:nvSpPr>
+          <p:cNvPr id="26" name="Shape 23"/>
+          <p:cNvSpPr/>
+          <p:nvPr/>
+        </p:nvSpPr>
+        <p:spPr>
+          <a:xfrm>
+            <a:off x="4338218" y="5806440"/>
+            <a:ext cx="146304" cy="0"/>
+          </a:xfrm>
+          <a:prstGeom prst="line">
+            <a:avLst/>
+          </a:prstGeom>
+          <a:noFill/>
+          <a:ln w="12700">
+            <a:solidFill>
+              <a:srgbClr val="2A2B33"/>
+            </a:solidFill>
+            <a:prstDash val="solid"/>
+          </a:ln>
+        </p:spPr>
+      </p:sp>
+      <p:sp>
+        <p:nvSpPr>
+          <p:cNvPr id="27" name="Shape 24"/>
+          <p:cNvSpPr/>
+          <p:nvPr/>
+        </p:nvSpPr>
+        <p:spPr>
+          <a:xfrm>
+            <a:off x="4338218" y="5660136"/>
+            <a:ext cx="0" cy="146304"/>
+          </a:xfrm>
+          <a:prstGeom prst="line">
+            <a:avLst/>
+          </a:prstGeom>
+          <a:noFill/>
+          <a:ln w="12700">
+            <a:solidFill>
+              <a:srgbClr val="2A2B33"/>
+            </a:solidFill>
+            <a:prstDash val="solid"/>
+          </a:ln>
+        </p:spPr>
+      </p:sp>
+      <p:sp>
+        <p:nvSpPr>
+          <p:cNvPr id="28" name="Shape 25"/>
+          <p:cNvSpPr/>
+          <p:nvPr/>
+        </p:nvSpPr>
+        <p:spPr>
+          <a:xfrm>
+            <a:off x="7707173" y="5806440"/>
+            <a:ext cx="146304" cy="0"/>
+          </a:xfrm>
+          <a:prstGeom prst="line">
+            <a:avLst/>
+          </a:prstGeom>
+          <a:noFill/>
+          <a:ln w="12700">
+            <a:solidFill>
+              <a:srgbClr val="2A2B33"/>
+            </a:solidFill>
+            <a:prstDash val="solid"/>
+          </a:ln>
+        </p:spPr>
+      </p:sp>
+      <p:sp>
+        <p:nvSpPr>
+          <p:cNvPr id="29" name="Shape 26"/>
+          <p:cNvSpPr/>
+          <p:nvPr/>
+        </p:nvSpPr>
+        <p:spPr>
+          <a:xfrm>
+            <a:off x="7853477" y="5660136"/>
+            <a:ext cx="0" cy="146304"/>
+          </a:xfrm>
+          <a:prstGeom prst="line">
+            <a:avLst/>
+          </a:prstGeom>
+          <a:noFill/>
+          <a:ln w="12700">
+            <a:solidFill>
+              <a:srgbClr val="2A2B33"/>
+            </a:solidFill>
+            <a:prstDash val="solid"/>
+          </a:ln>
+        </p:spPr>
+      </p:sp>
+      <p:sp>
+        <p:nvSpPr>
+          <p:cNvPr id="30" name="Text 27"/>
+          <p:cNvSpPr txBox="1"/>
+          <p:nvPr/>
+        </p:nvSpPr>
+        <p:spPr>
+          <a:xfrm>
+            <a:off x="4612538" y="2606040"/>
+            <a:ext cx="3058058" cy="1051560"/>
+          </a:xfrm>
+          <a:prstGeom prst="rect">
+            <a:avLst/>
+          </a:prstGeom>
+          <a:noFill/>
+          <a:ln/>
+        </p:spPr>
+        <p:txBody>
+          <a:bodyPr wrap="square" lIns="0" tIns="0" rIns="0" bIns="0" rtlCol="0" anchor="ctr"/>
+          <a:lstStyle/>
+          <a:p>
+            <a:pPr indent="0" marL="0">
+              <a:buNone/>
+            </a:pPr>
+            <a:r>
+              <a:rPr lang="en-US" sz="6400" b="1" dirty="0">
+                <a:solidFill>
+                  <a:srgbClr val="F5F2EC"/>
+                </a:solidFill>
+                <a:latin typeface="Space Grotesk" pitchFamily="34" charset="0"/>
+                <a:ea typeface="Space Grotesk" pitchFamily="34" charset="-122"/>
+                <a:cs typeface="Space Grotesk" pitchFamily="34" charset="-120"/>
+              </a:rPr>
+              <a:t>~70%</a:t>
+            </a:r>
+            <a:endParaRPr lang="en-US" sz="6400" dirty="0"/>
+          </a:p>
+        </p:txBody>
+      </p:sp>
+      <p:sp>
+        <p:nvSpPr>
+          <p:cNvPr id="31" name="Text 28"/>
+          <p:cNvSpPr txBox="1"/>
+          <p:nvPr/>
+        </p:nvSpPr>
+        <p:spPr>
+          <a:xfrm>
+            <a:off x="4612538" y="3840480"/>
             <a:ext cx="2966618" cy="1234440"/>
           </a:xfrm>
           <a:prstGeom prst="rect">
@@ -6228,7 +6536,7 @@
                 <a:ea typeface="Inter" pitchFamily="34" charset="-122"/>
                 <a:cs typeface="Inter" pitchFamily="34" charset="-120"/>
               </a:rPr>
-              <a:t>Organizaciones que capturan valor sustancial de su inversión en IA.</a:t>
+              <a:t>del valor de la IA depende de repensar el componente humano, en la experiencia de BCG.</a:t>
             </a:r>
             <a:endParaRPr lang="en-US" sz="1500" dirty="0"/>
           </a:p>
@@ -6236,14 +6544,14 @@
       </p:sp>
       <p:sp>
         <p:nvSpPr>
-          <p:cNvPr id="20" name="Text 18"/>
-          <p:cNvSpPr txBox="1"/>
-          <p:nvPr/>
-        </p:nvSpPr>
-        <p:spPr>
-          <a:xfrm>
-            <a:off x="822960" y="5120640"/>
-            <a:ext cx="2966618" cy="548640"/>
+          <p:cNvPr id="32" name="Text 29"/>
+          <p:cNvSpPr txBox="1"/>
+          <p:nvPr/>
+        </p:nvSpPr>
+        <p:spPr>
+          <a:xfrm>
+            <a:off x="4612538" y="5166360"/>
+            <a:ext cx="2966618" cy="502920"/>
           </a:xfrm>
           <a:prstGeom prst="rect">
             <a:avLst/>
@@ -6270,7 +6578,7 @@
                 <a:ea typeface="Space Mono" pitchFamily="34" charset="-122"/>
                 <a:cs typeface="Space Mono" pitchFamily="34" charset="-120"/>
               </a:rPr>
-              <a:t>FUENTE · [FUENTE Y FECHA PENDIENTES RES-01]</a:t>
+              <a:t>FUENTE · BCG, 2026 · AI Transformation Is a Workforce Transformation</a:t>
             </a:r>
             <a:endParaRPr lang="en-US" sz="800" dirty="0"/>
           </a:p>
@@ -6278,13 +6586,13 @@
       </p:sp>
       <p:sp>
         <p:nvSpPr>
-          <p:cNvPr id="21" name="Shape 19"/>
-          <p:cNvSpPr/>
-          <p:nvPr/>
-        </p:nvSpPr>
-        <p:spPr>
-          <a:xfrm>
-            <a:off x="4338218" y="2377440"/>
+          <p:cNvPr id="33" name="Shape 30"/>
+          <p:cNvSpPr/>
+          <p:nvPr/>
+        </p:nvSpPr>
+        <p:spPr>
+          <a:xfrm>
+            <a:off x="8127797" y="2377440"/>
             <a:ext cx="3515258" cy="3429000"/>
           </a:xfrm>
           <a:prstGeom prst="rect">
@@ -6298,13 +6606,13 @@
       </p:sp>
       <p:sp>
         <p:nvSpPr>
-          <p:cNvPr id="22" name="Shape 20"/>
-          <p:cNvSpPr/>
-          <p:nvPr/>
-        </p:nvSpPr>
-        <p:spPr>
-          <a:xfrm>
-            <a:off x="4338218" y="2377440"/>
+          <p:cNvPr id="34" name="Shape 31"/>
+          <p:cNvSpPr/>
+          <p:nvPr/>
+        </p:nvSpPr>
+        <p:spPr>
+          <a:xfrm>
+            <a:off x="8127797" y="2377440"/>
             <a:ext cx="146304" cy="0"/>
           </a:xfrm>
           <a:prstGeom prst="line">
@@ -6321,13 +6629,13 @@
       </p:sp>
       <p:sp>
         <p:nvSpPr>
-          <p:cNvPr id="23" name="Shape 21"/>
-          <p:cNvSpPr/>
-          <p:nvPr/>
-        </p:nvSpPr>
-        <p:spPr>
-          <a:xfrm>
-            <a:off x="4338218" y="2377440"/>
+          <p:cNvPr id="35" name="Shape 32"/>
+          <p:cNvSpPr/>
+          <p:nvPr/>
+        </p:nvSpPr>
+        <p:spPr>
+          <a:xfrm>
+            <a:off x="8127797" y="2377440"/>
             <a:ext cx="0" cy="146304"/>
           </a:xfrm>
           <a:prstGeom prst="line">
@@ -6344,13 +6652,13 @@
       </p:sp>
       <p:sp>
         <p:nvSpPr>
-          <p:cNvPr id="24" name="Shape 22"/>
-          <p:cNvSpPr/>
-          <p:nvPr/>
-        </p:nvSpPr>
-        <p:spPr>
-          <a:xfrm>
-            <a:off x="7707173" y="2377440"/>
+          <p:cNvPr id="36" name="Shape 33"/>
+          <p:cNvSpPr/>
+          <p:nvPr/>
+        </p:nvSpPr>
+        <p:spPr>
+          <a:xfrm>
+            <a:off x="11496751" y="2377440"/>
             <a:ext cx="146304" cy="0"/>
           </a:xfrm>
           <a:prstGeom prst="line">
@@ -6367,13 +6675,13 @@
       </p:sp>
       <p:sp>
         <p:nvSpPr>
-          <p:cNvPr id="25" name="Shape 23"/>
-          <p:cNvSpPr/>
-          <p:nvPr/>
-        </p:nvSpPr>
-        <p:spPr>
-          <a:xfrm>
-            <a:off x="7853477" y="2377440"/>
+          <p:cNvPr id="37" name="Shape 34"/>
+          <p:cNvSpPr/>
+          <p:nvPr/>
+        </p:nvSpPr>
+        <p:spPr>
+          <a:xfrm>
+            <a:off x="11643055" y="2377440"/>
             <a:ext cx="0" cy="146304"/>
           </a:xfrm>
           <a:prstGeom prst="line">
@@ -6390,13 +6698,13 @@
       </p:sp>
       <p:sp>
         <p:nvSpPr>
-          <p:cNvPr id="26" name="Shape 24"/>
-          <p:cNvSpPr/>
-          <p:nvPr/>
-        </p:nvSpPr>
-        <p:spPr>
-          <a:xfrm>
-            <a:off x="4338218" y="5806440"/>
+          <p:cNvPr id="38" name="Shape 35"/>
+          <p:cNvSpPr/>
+          <p:nvPr/>
+        </p:nvSpPr>
+        <p:spPr>
+          <a:xfrm>
+            <a:off x="8127797" y="5806440"/>
             <a:ext cx="146304" cy="0"/>
           </a:xfrm>
           <a:prstGeom prst="line">
@@ -6413,13 +6721,13 @@
       </p:sp>
       <p:sp>
         <p:nvSpPr>
-          <p:cNvPr id="27" name="Shape 25"/>
-          <p:cNvSpPr/>
-          <p:nvPr/>
-        </p:nvSpPr>
-        <p:spPr>
-          <a:xfrm>
-            <a:off x="4338218" y="5660136"/>
+          <p:cNvPr id="39" name="Shape 36"/>
+          <p:cNvSpPr/>
+          <p:nvPr/>
+        </p:nvSpPr>
+        <p:spPr>
+          <a:xfrm>
+            <a:off x="8127797" y="5660136"/>
             <a:ext cx="0" cy="146304"/>
           </a:xfrm>
           <a:prstGeom prst="line">
@@ -6436,13 +6744,13 @@
       </p:sp>
       <p:sp>
         <p:nvSpPr>
-          <p:cNvPr id="28" name="Shape 26"/>
-          <p:cNvSpPr/>
-          <p:nvPr/>
-        </p:nvSpPr>
-        <p:spPr>
-          <a:xfrm>
-            <a:off x="7707173" y="5806440"/>
+          <p:cNvPr id="40" name="Shape 37"/>
+          <p:cNvSpPr/>
+          <p:nvPr/>
+        </p:nvSpPr>
+        <p:spPr>
+          <a:xfrm>
+            <a:off x="11496751" y="5806440"/>
             <a:ext cx="146304" cy="0"/>
           </a:xfrm>
           <a:prstGeom prst="line">
@@ -6459,13 +6767,13 @@
       </p:sp>
       <p:sp>
         <p:nvSpPr>
-          <p:cNvPr id="29" name="Shape 27"/>
-          <p:cNvSpPr/>
-          <p:nvPr/>
-        </p:nvSpPr>
-        <p:spPr>
-          <a:xfrm>
-            <a:off x="7853477" y="5660136"/>
+          <p:cNvPr id="41" name="Shape 38"/>
+          <p:cNvSpPr/>
+          <p:nvPr/>
+        </p:nvSpPr>
+        <p:spPr>
+          <a:xfrm>
+            <a:off x="11643055" y="5660136"/>
             <a:ext cx="0" cy="146304"/>
           </a:xfrm>
           <a:prstGeom prst="line">
@@ -6482,36 +6790,14 @@
       </p:sp>
       <p:sp>
         <p:nvSpPr>
-          <p:cNvPr id="30" name="Shape 28"/>
-          <p:cNvSpPr/>
-          <p:nvPr/>
-        </p:nvSpPr>
-        <p:spPr>
-          <a:xfrm>
-            <a:off x="4612538" y="2697480"/>
-            <a:ext cx="2966618" cy="914400"/>
-          </a:xfrm>
-          <a:prstGeom prst="rect">
-            <a:avLst/>
-          </a:prstGeom>
-          <a:ln w="9525">
-            <a:solidFill>
-              <a:srgbClr val="E9663C"/>
-            </a:solidFill>
-            <a:prstDash val="solid"/>
-          </a:ln>
-        </p:spPr>
-      </p:sp>
-      <p:sp>
-        <p:nvSpPr>
-          <p:cNvPr id="31" name="Text 29"/>
-          <p:cNvSpPr txBox="1"/>
-          <p:nvPr/>
-        </p:nvSpPr>
-        <p:spPr>
-          <a:xfrm>
-            <a:off x="4722266" y="2761488"/>
-            <a:ext cx="2747162" cy="786384"/>
+          <p:cNvPr id="42" name="Text 39"/>
+          <p:cNvSpPr txBox="1"/>
+          <p:nvPr/>
+        </p:nvSpPr>
+        <p:spPr>
+          <a:xfrm>
+            <a:off x="8402117" y="2606040"/>
+            <a:ext cx="3058058" cy="1051560"/>
           </a:xfrm>
           <a:prstGeom prst="rect">
             <a:avLst/>
@@ -6527,30 +6813,114 @@
               <a:buNone/>
             </a:pPr>
             <a:r>
-              <a:rPr lang="en-US" sz="1200" b="1" spc="100" kern="0" dirty="0">
-                <a:solidFill>
-                  <a:srgbClr val="E9663C"/>
+              <a:rPr lang="en-US" sz="6400" b="1" dirty="0">
+                <a:solidFill>
+                  <a:srgbClr val="F5F2EC"/>
+                </a:solidFill>
+                <a:latin typeface="Space Grotesk" pitchFamily="34" charset="0"/>
+                <a:ea typeface="Space Grotesk" pitchFamily="34" charset="-122"/>
+                <a:cs typeface="Space Grotesk" pitchFamily="34" charset="-120"/>
+              </a:rPr>
+              <a:t>56%</a:t>
+            </a:r>
+            <a:endParaRPr lang="en-US" sz="6400" dirty="0"/>
+          </a:p>
+        </p:txBody>
+      </p:sp>
+      <p:sp>
+        <p:nvSpPr>
+          <p:cNvPr id="43" name="Text 40"/>
+          <p:cNvSpPr txBox="1"/>
+          <p:nvPr/>
+        </p:nvSpPr>
+        <p:spPr>
+          <a:xfrm>
+            <a:off x="8402117" y="3840480"/>
+            <a:ext cx="2966618" cy="1234440"/>
+          </a:xfrm>
+          <a:prstGeom prst="rect">
+            <a:avLst/>
+          </a:prstGeom>
+          <a:noFill/>
+          <a:ln/>
+        </p:spPr>
+        <p:txBody>
+          <a:bodyPr wrap="square" lIns="0" tIns="0" rIns="0" bIns="0" rtlCol="0" anchor="t"/>
+          <a:lstStyle/>
+          <a:p>
+            <a:pPr indent="0" marL="0">
+              <a:lnSpc>
+                <a:spcPct val="115000"/>
+              </a:lnSpc>
+              <a:buNone/>
+            </a:pPr>
+            <a:r>
+              <a:rPr lang="en-US" sz="1500" dirty="0">
+                <a:solidFill>
+                  <a:srgbClr val="F5F2EC"/>
+                </a:solidFill>
+                <a:latin typeface="Inter" pitchFamily="34" charset="0"/>
+                <a:ea typeface="Inter" pitchFamily="34" charset="-122"/>
+                <a:cs typeface="Inter" pitchFamily="34" charset="-120"/>
+              </a:rPr>
+              <a:t>de las empresas en México aún no identifica con claridad el valor de negocio de la IA.</a:t>
+            </a:r>
+            <a:endParaRPr lang="en-US" sz="1500" dirty="0"/>
+          </a:p>
+        </p:txBody>
+      </p:sp>
+      <p:sp>
+        <p:nvSpPr>
+          <p:cNvPr id="44" name="Text 41"/>
+          <p:cNvSpPr txBox="1"/>
+          <p:nvPr/>
+        </p:nvSpPr>
+        <p:spPr>
+          <a:xfrm>
+            <a:off x="8402117" y="5166360"/>
+            <a:ext cx="2966618" cy="502920"/>
+          </a:xfrm>
+          <a:prstGeom prst="rect">
+            <a:avLst/>
+          </a:prstGeom>
+          <a:noFill/>
+          <a:ln/>
+        </p:spPr>
+        <p:txBody>
+          <a:bodyPr wrap="square" lIns="0" tIns="0" rIns="0" bIns="0" rtlCol="0" anchor="b"/>
+          <a:lstStyle/>
+          <a:p>
+            <a:pPr indent="0" marL="0">
+              <a:lnSpc>
+                <a:spcPct val="110000"/>
+              </a:lnSpc>
+              <a:buNone/>
+            </a:pPr>
+            <a:r>
+              <a:rPr lang="en-US" sz="800" dirty="0">
+                <a:solidFill>
+                  <a:srgbClr val="A7AAB5"/>
                 </a:solidFill>
                 <a:latin typeface="Space Mono" pitchFamily="34" charset="0"/>
                 <a:ea typeface="Space Mono" pitchFamily="34" charset="-122"/>
                 <a:cs typeface="Space Mono" pitchFamily="34" charset="-120"/>
               </a:rPr>
-              <a:t>[CIFRA PENDIENTE RES-01]</a:t>
-            </a:r>
-            <a:endParaRPr lang="en-US" sz="1200" dirty="0"/>
-          </a:p>
-        </p:txBody>
-      </p:sp>
-      <p:sp>
-        <p:nvSpPr>
-          <p:cNvPr id="32" name="Text 30"/>
-          <p:cNvSpPr txBox="1"/>
-          <p:nvPr/>
-        </p:nvSpPr>
-        <p:spPr>
-          <a:xfrm>
-            <a:off x="4612538" y="3840480"/>
-            <a:ext cx="2966618" cy="1234440"/>
+              <a:t>FUENTE · KPMG México, 2025 · Panorama de la IA en México y Centroamérica</a:t>
+            </a:r>
+            <a:endParaRPr lang="en-US" sz="800" dirty="0"/>
+          </a:p>
+        </p:txBody>
+      </p:sp>
+      <p:sp>
+        <p:nvSpPr>
+          <p:cNvPr id="45" name="Text 42"/>
+          <p:cNvSpPr txBox="1"/>
+          <p:nvPr/>
+        </p:nvSpPr>
+        <p:spPr>
+          <a:xfrm>
+            <a:off x="548640" y="5943600"/>
+            <a:ext cx="11094415" cy="274320"/>
           </a:xfrm>
           <a:prstGeom prst="rect">
             <a:avLst/>
@@ -6564,453 +6934,20 @@
           <a:p>
             <a:pPr indent="0" marL="0">
               <a:lnSpc>
-                <a:spcPct val="115000"/>
+                <a:spcPct val="120000"/>
               </a:lnSpc>
               <a:buNone/>
             </a:pPr>
             <a:r>
-              <a:rPr lang="en-US" sz="1500" dirty="0">
-                <a:solidFill>
-                  <a:srgbClr val="F5F2EC"/>
+              <a:rPr lang="en-US" sz="1100" dirty="0">
+                <a:solidFill>
+                  <a:srgbClr val="A7AAB5"/>
                 </a:solidFill>
                 <a:latin typeface="Inter" pitchFamily="34" charset="0"/>
                 <a:ea typeface="Inter" pitchFamily="34" charset="-122"/>
                 <a:cs typeface="Inter" pitchFamily="34" charset="-120"/>
               </a:rPr>
-              <a:t>Probabilidad de no ver retorno cuando el enfoque es solo tecnológico.</a:t>
-            </a:r>
-            <a:endParaRPr lang="en-US" sz="1500" dirty="0"/>
-          </a:p>
-        </p:txBody>
-      </p:sp>
-      <p:sp>
-        <p:nvSpPr>
-          <p:cNvPr id="33" name="Text 31"/>
-          <p:cNvSpPr txBox="1"/>
-          <p:nvPr/>
-        </p:nvSpPr>
-        <p:spPr>
-          <a:xfrm>
-            <a:off x="4612538" y="5120640"/>
-            <a:ext cx="2966618" cy="548640"/>
-          </a:xfrm>
-          <a:prstGeom prst="rect">
-            <a:avLst/>
-          </a:prstGeom>
-          <a:noFill/>
-          <a:ln/>
-        </p:spPr>
-        <p:txBody>
-          <a:bodyPr wrap="square" lIns="0" tIns="0" rIns="0" bIns="0" rtlCol="0" anchor="b"/>
-          <a:lstStyle/>
-          <a:p>
-            <a:pPr indent="0" marL="0">
-              <a:lnSpc>
-                <a:spcPct val="110000"/>
-              </a:lnSpc>
-              <a:buNone/>
-            </a:pPr>
-            <a:r>
-              <a:rPr lang="en-US" sz="800" dirty="0">
-                <a:solidFill>
-                  <a:srgbClr val="A7AAB5"/>
-                </a:solidFill>
-                <a:latin typeface="Space Mono" pitchFamily="34" charset="0"/>
-                <a:ea typeface="Space Mono" pitchFamily="34" charset="-122"/>
-                <a:cs typeface="Space Mono" pitchFamily="34" charset="-120"/>
-              </a:rPr>
-              <a:t>FUENTE · [FUENTE Y FECHA PENDIENTES RES-01]</a:t>
-            </a:r>
-            <a:endParaRPr lang="en-US" sz="800" dirty="0"/>
-          </a:p>
-        </p:txBody>
-      </p:sp>
-      <p:sp>
-        <p:nvSpPr>
-          <p:cNvPr id="34" name="Shape 32"/>
-          <p:cNvSpPr/>
-          <p:nvPr/>
-        </p:nvSpPr>
-        <p:spPr>
-          <a:xfrm>
-            <a:off x="8127797" y="2377440"/>
-            <a:ext cx="3515258" cy="3429000"/>
-          </a:xfrm>
-          <a:prstGeom prst="rect">
-            <a:avLst/>
-          </a:prstGeom>
-          <a:solidFill>
-            <a:srgbClr val="15161D"/>
-          </a:solidFill>
-          <a:ln/>
-        </p:spPr>
-      </p:sp>
-      <p:sp>
-        <p:nvSpPr>
-          <p:cNvPr id="35" name="Shape 33"/>
-          <p:cNvSpPr/>
-          <p:nvPr/>
-        </p:nvSpPr>
-        <p:spPr>
-          <a:xfrm>
-            <a:off x="8127797" y="2377440"/>
-            <a:ext cx="146304" cy="0"/>
-          </a:xfrm>
-          <a:prstGeom prst="line">
-            <a:avLst/>
-          </a:prstGeom>
-          <a:noFill/>
-          <a:ln w="12700">
-            <a:solidFill>
-              <a:srgbClr val="2A2B33"/>
-            </a:solidFill>
-            <a:prstDash val="solid"/>
-          </a:ln>
-        </p:spPr>
-      </p:sp>
-      <p:sp>
-        <p:nvSpPr>
-          <p:cNvPr id="36" name="Shape 34"/>
-          <p:cNvSpPr/>
-          <p:nvPr/>
-        </p:nvSpPr>
-        <p:spPr>
-          <a:xfrm>
-            <a:off x="8127797" y="2377440"/>
-            <a:ext cx="0" cy="146304"/>
-          </a:xfrm>
-          <a:prstGeom prst="line">
-            <a:avLst/>
-          </a:prstGeom>
-          <a:noFill/>
-          <a:ln w="12700">
-            <a:solidFill>
-              <a:srgbClr val="2A2B33"/>
-            </a:solidFill>
-            <a:prstDash val="solid"/>
-          </a:ln>
-        </p:spPr>
-      </p:sp>
-      <p:sp>
-        <p:nvSpPr>
-          <p:cNvPr id="37" name="Shape 35"/>
-          <p:cNvSpPr/>
-          <p:nvPr/>
-        </p:nvSpPr>
-        <p:spPr>
-          <a:xfrm>
-            <a:off x="11496751" y="2377440"/>
-            <a:ext cx="146304" cy="0"/>
-          </a:xfrm>
-          <a:prstGeom prst="line">
-            <a:avLst/>
-          </a:prstGeom>
-          <a:noFill/>
-          <a:ln w="12700">
-            <a:solidFill>
-              <a:srgbClr val="2A2B33"/>
-            </a:solidFill>
-            <a:prstDash val="solid"/>
-          </a:ln>
-        </p:spPr>
-      </p:sp>
-      <p:sp>
-        <p:nvSpPr>
-          <p:cNvPr id="38" name="Shape 36"/>
-          <p:cNvSpPr/>
-          <p:nvPr/>
-        </p:nvSpPr>
-        <p:spPr>
-          <a:xfrm>
-            <a:off x="11643055" y="2377440"/>
-            <a:ext cx="0" cy="146304"/>
-          </a:xfrm>
-          <a:prstGeom prst="line">
-            <a:avLst/>
-          </a:prstGeom>
-          <a:noFill/>
-          <a:ln w="12700">
-            <a:solidFill>
-              <a:srgbClr val="2A2B33"/>
-            </a:solidFill>
-            <a:prstDash val="solid"/>
-          </a:ln>
-        </p:spPr>
-      </p:sp>
-      <p:sp>
-        <p:nvSpPr>
-          <p:cNvPr id="39" name="Shape 37"/>
-          <p:cNvSpPr/>
-          <p:nvPr/>
-        </p:nvSpPr>
-        <p:spPr>
-          <a:xfrm>
-            <a:off x="8127797" y="5806440"/>
-            <a:ext cx="146304" cy="0"/>
-          </a:xfrm>
-          <a:prstGeom prst="line">
-            <a:avLst/>
-          </a:prstGeom>
-          <a:noFill/>
-          <a:ln w="12700">
-            <a:solidFill>
-              <a:srgbClr val="2A2B33"/>
-            </a:solidFill>
-            <a:prstDash val="solid"/>
-          </a:ln>
-        </p:spPr>
-      </p:sp>
-      <p:sp>
-        <p:nvSpPr>
-          <p:cNvPr id="40" name="Shape 38"/>
-          <p:cNvSpPr/>
-          <p:nvPr/>
-        </p:nvSpPr>
-        <p:spPr>
-          <a:xfrm>
-            <a:off x="8127797" y="5660136"/>
-            <a:ext cx="0" cy="146304"/>
-          </a:xfrm>
-          <a:prstGeom prst="line">
-            <a:avLst/>
-          </a:prstGeom>
-          <a:noFill/>
-          <a:ln w="12700">
-            <a:solidFill>
-              <a:srgbClr val="2A2B33"/>
-            </a:solidFill>
-            <a:prstDash val="solid"/>
-          </a:ln>
-        </p:spPr>
-      </p:sp>
-      <p:sp>
-        <p:nvSpPr>
-          <p:cNvPr id="41" name="Shape 39"/>
-          <p:cNvSpPr/>
-          <p:nvPr/>
-        </p:nvSpPr>
-        <p:spPr>
-          <a:xfrm>
-            <a:off x="11496751" y="5806440"/>
-            <a:ext cx="146304" cy="0"/>
-          </a:xfrm>
-          <a:prstGeom prst="line">
-            <a:avLst/>
-          </a:prstGeom>
-          <a:noFill/>
-          <a:ln w="12700">
-            <a:solidFill>
-              <a:srgbClr val="2A2B33"/>
-            </a:solidFill>
-            <a:prstDash val="solid"/>
-          </a:ln>
-        </p:spPr>
-      </p:sp>
-      <p:sp>
-        <p:nvSpPr>
-          <p:cNvPr id="42" name="Shape 40"/>
-          <p:cNvSpPr/>
-          <p:nvPr/>
-        </p:nvSpPr>
-        <p:spPr>
-          <a:xfrm>
-            <a:off x="11643055" y="5660136"/>
-            <a:ext cx="0" cy="146304"/>
-          </a:xfrm>
-          <a:prstGeom prst="line">
-            <a:avLst/>
-          </a:prstGeom>
-          <a:noFill/>
-          <a:ln w="12700">
-            <a:solidFill>
-              <a:srgbClr val="2A2B33"/>
-            </a:solidFill>
-            <a:prstDash val="solid"/>
-          </a:ln>
-        </p:spPr>
-      </p:sp>
-      <p:sp>
-        <p:nvSpPr>
-          <p:cNvPr id="43" name="Shape 41"/>
-          <p:cNvSpPr/>
-          <p:nvPr/>
-        </p:nvSpPr>
-        <p:spPr>
-          <a:xfrm>
-            <a:off x="8402117" y="2697480"/>
-            <a:ext cx="2966618" cy="914400"/>
-          </a:xfrm>
-          <a:prstGeom prst="rect">
-            <a:avLst/>
-          </a:prstGeom>
-          <a:ln w="9525">
-            <a:solidFill>
-              <a:srgbClr val="E9663C"/>
-            </a:solidFill>
-            <a:prstDash val="solid"/>
-          </a:ln>
-        </p:spPr>
-      </p:sp>
-      <p:sp>
-        <p:nvSpPr>
-          <p:cNvPr id="44" name="Text 42"/>
-          <p:cNvSpPr txBox="1"/>
-          <p:nvPr/>
-        </p:nvSpPr>
-        <p:spPr>
-          <a:xfrm>
-            <a:off x="8511845" y="2761488"/>
-            <a:ext cx="2747162" cy="786384"/>
-          </a:xfrm>
-          <a:prstGeom prst="rect">
-            <a:avLst/>
-          </a:prstGeom>
-          <a:noFill/>
-          <a:ln/>
-        </p:spPr>
-        <p:txBody>
-          <a:bodyPr wrap="square" lIns="0" tIns="0" rIns="0" bIns="0" rtlCol="0" anchor="ctr"/>
-          <a:lstStyle/>
-          <a:p>
-            <a:pPr indent="0" marL="0">
-              <a:buNone/>
-            </a:pPr>
-            <a:r>
-              <a:rPr lang="en-US" sz="1200" b="1" spc="100" kern="0" dirty="0">
-                <a:solidFill>
-                  <a:srgbClr val="E9663C"/>
-                </a:solidFill>
-                <a:latin typeface="Space Mono" pitchFamily="34" charset="0"/>
-                <a:ea typeface="Space Mono" pitchFamily="34" charset="-122"/>
-                <a:cs typeface="Space Mono" pitchFamily="34" charset="-120"/>
-              </a:rPr>
-              <a:t>[CIFRA PENDIENTE RES-01]</a:t>
-            </a:r>
-            <a:endParaRPr lang="en-US" sz="1200" dirty="0"/>
-          </a:p>
-        </p:txBody>
-      </p:sp>
-      <p:sp>
-        <p:nvSpPr>
-          <p:cNvPr id="45" name="Text 43"/>
-          <p:cNvSpPr txBox="1"/>
-          <p:nvPr/>
-        </p:nvSpPr>
-        <p:spPr>
-          <a:xfrm>
-            <a:off x="8402117" y="3840480"/>
-            <a:ext cx="2966618" cy="1234440"/>
-          </a:xfrm>
-          <a:prstGeom prst="rect">
-            <a:avLst/>
-          </a:prstGeom>
-          <a:noFill/>
-          <a:ln/>
-        </p:spPr>
-        <p:txBody>
-          <a:bodyPr wrap="square" lIns="0" tIns="0" rIns="0" bIns="0" rtlCol="0" anchor="t"/>
-          <a:lstStyle/>
-          <a:p>
-            <a:pPr indent="0" marL="0">
-              <a:lnSpc>
-                <a:spcPct val="115000"/>
-              </a:lnSpc>
-              <a:buNone/>
-            </a:pPr>
-            <a:r>
-              <a:rPr lang="en-US" sz="1500" dirty="0">
-                <a:solidFill>
-                  <a:srgbClr val="F5F2EC"/>
-                </a:solidFill>
-                <a:latin typeface="Inter" pitchFamily="34" charset="0"/>
-                <a:ea typeface="Inter" pitchFamily="34" charset="-122"/>
-                <a:cs typeface="Inter" pitchFamily="34" charset="-120"/>
-              </a:rPr>
-              <a:t>Peso de la gestión del cambio y la cultura en la agenda de la dirección de personas.</a:t>
-            </a:r>
-            <a:endParaRPr lang="en-US" sz="1500" dirty="0"/>
-          </a:p>
-        </p:txBody>
-      </p:sp>
-      <p:sp>
-        <p:nvSpPr>
-          <p:cNvPr id="46" name="Text 44"/>
-          <p:cNvSpPr txBox="1"/>
-          <p:nvPr/>
-        </p:nvSpPr>
-        <p:spPr>
-          <a:xfrm>
-            <a:off x="8402117" y="5120640"/>
-            <a:ext cx="2966618" cy="548640"/>
-          </a:xfrm>
-          <a:prstGeom prst="rect">
-            <a:avLst/>
-          </a:prstGeom>
-          <a:noFill/>
-          <a:ln/>
-        </p:spPr>
-        <p:txBody>
-          <a:bodyPr wrap="square" lIns="0" tIns="0" rIns="0" bIns="0" rtlCol="0" anchor="b"/>
-          <a:lstStyle/>
-          <a:p>
-            <a:pPr indent="0" marL="0">
-              <a:lnSpc>
-                <a:spcPct val="110000"/>
-              </a:lnSpc>
-              <a:buNone/>
-            </a:pPr>
-            <a:r>
-              <a:rPr lang="en-US" sz="800" dirty="0">
-                <a:solidFill>
-                  <a:srgbClr val="A7AAB5"/>
-                </a:solidFill>
-                <a:latin typeface="Space Mono" pitchFamily="34" charset="0"/>
-                <a:ea typeface="Space Mono" pitchFamily="34" charset="-122"/>
-                <a:cs typeface="Space Mono" pitchFamily="34" charset="-120"/>
-              </a:rPr>
-              <a:t>FUENTE · [FUENTE Y FECHA PENDIENTES RES-01]</a:t>
-            </a:r>
-            <a:endParaRPr lang="en-US" sz="800" dirty="0"/>
-          </a:p>
-        </p:txBody>
-      </p:sp>
-      <p:sp>
-        <p:nvSpPr>
-          <p:cNvPr id="47" name="Text 45"/>
-          <p:cNvSpPr txBox="1"/>
-          <p:nvPr/>
-        </p:nvSpPr>
-        <p:spPr>
-          <a:xfrm>
-            <a:off x="548640" y="5943600"/>
-            <a:ext cx="11094415" cy="274320"/>
-          </a:xfrm>
-          <a:prstGeom prst="rect">
-            <a:avLst/>
-          </a:prstGeom>
-          <a:noFill/>
-          <a:ln/>
-        </p:spPr>
-        <p:txBody>
-          <a:bodyPr wrap="square" lIns="0" tIns="0" rIns="0" bIns="0" rtlCol="0" anchor="t"/>
-          <a:lstStyle/>
-          <a:p>
-            <a:pPr indent="0" marL="0">
-              <a:lnSpc>
-                <a:spcPct val="120000"/>
-              </a:lnSpc>
-              <a:buNone/>
-            </a:pPr>
-            <a:r>
-              <a:rPr lang="en-US" sz="1100" dirty="0">
-                <a:solidFill>
-                  <a:srgbClr val="A7AAB5"/>
-                </a:solidFill>
-                <a:latin typeface="Inter" pitchFamily="34" charset="0"/>
-                <a:ea typeface="Inter" pitchFamily="34" charset="-122"/>
-                <a:cs typeface="Inter" pitchFamily="34" charset="-120"/>
-              </a:rPr>
-              <a:t>Comprar software o IA no equivale a adopción ni a retorno. Cada cifra se publica solo con fuente verificable y fecha.</a:t>
+              <a:t>Comprar software o IA no equivale a adopción ni a retorno. Cifras globales (BCG) y de México (KPMG); fuentes en las notas.</a:t>
             </a:r>
             <a:endParaRPr lang="en-US" sz="1100" dirty="0"/>
           </a:p>
@@ -7245,7 +7182,7 @@
         <p:spPr>
           <a:xfrm>
             <a:off x="548640" y="914400"/>
-            <a:ext cx="5394960" cy="2057400"/>
+            <a:ext cx="5394960" cy="2068576"/>
           </a:xfrm>
           <a:prstGeom prst="rect">
             <a:avLst/>
@@ -7286,8 +7223,8 @@
         </p:nvSpPr>
         <p:spPr>
           <a:xfrm>
-            <a:off x="548640" y="3154680"/>
-            <a:ext cx="5120640" cy="2651760"/>
+            <a:off x="548640" y="3165856"/>
+            <a:ext cx="5120640" cy="2777744"/>
           </a:xfrm>
           <a:prstGeom prst="rect">
             <a:avLst/>
@@ -7512,7 +7449,7 @@
         </p:nvSpPr>
         <p:spPr>
           <a:xfrm>
-            <a:off x="6720840" y="1143000"/>
+            <a:off x="6720840" y="1179576"/>
             <a:ext cx="548640" cy="274320"/>
           </a:xfrm>
           <a:prstGeom prst="rect">
@@ -7552,19 +7489,22 @@
         <p:spPr>
           <a:xfrm>
             <a:off x="7360920" y="1143000"/>
-            <a:ext cx="4007815" cy="365760"/>
-          </a:xfrm>
-          <a:prstGeom prst="rect">
-            <a:avLst/>
-          </a:prstGeom>
-          <a:noFill/>
-          <a:ln/>
-        </p:spPr>
-        <p:txBody>
-          <a:bodyPr wrap="square" lIns="0" tIns="0" rIns="0" bIns="0" rtlCol="0" anchor="t"/>
-          <a:lstStyle/>
-          <a:p>
-            <a:pPr indent="0" marL="0">
+            <a:ext cx="4007815" cy="325628"/>
+          </a:xfrm>
+          <a:prstGeom prst="rect">
+            <a:avLst/>
+          </a:prstGeom>
+          <a:noFill/>
+          <a:ln/>
+        </p:spPr>
+        <p:txBody>
+          <a:bodyPr wrap="square" lIns="0" tIns="0" rIns="0" bIns="0" rtlCol="0" anchor="t"/>
+          <a:lstStyle/>
+          <a:p>
+            <a:pPr indent="0" marL="0">
+              <a:lnSpc>
+                <a:spcPct val="95000"/>
+              </a:lnSpc>
               <a:buNone/>
             </a:pPr>
             <a:r>
@@ -7590,8 +7530,8 @@
         </p:nvSpPr>
         <p:spPr>
           <a:xfrm>
-            <a:off x="7360920" y="1554480"/>
-            <a:ext cx="4007815" cy="701040"/>
+            <a:off x="7360920" y="1532636"/>
+            <a:ext cx="4007815" cy="814324"/>
           </a:xfrm>
           <a:prstGeom prst="rect">
             <a:avLst/>
@@ -7816,7 +7756,7 @@
         </p:nvSpPr>
         <p:spPr>
           <a:xfrm>
-            <a:off x="6720840" y="2895600"/>
+            <a:off x="6720840" y="2932176"/>
             <a:ext cx="548640" cy="274320"/>
           </a:xfrm>
           <a:prstGeom prst="rect">
@@ -7856,19 +7796,22 @@
         <p:spPr>
           <a:xfrm>
             <a:off x="7360920" y="2895600"/>
-            <a:ext cx="4007815" cy="365760"/>
-          </a:xfrm>
-          <a:prstGeom prst="rect">
-            <a:avLst/>
-          </a:prstGeom>
-          <a:noFill/>
-          <a:ln/>
-        </p:spPr>
-        <p:txBody>
-          <a:bodyPr wrap="square" lIns="0" tIns="0" rIns="0" bIns="0" rtlCol="0" anchor="t"/>
-          <a:lstStyle/>
-          <a:p>
-            <a:pPr indent="0" marL="0">
+            <a:ext cx="4007815" cy="325628"/>
+          </a:xfrm>
+          <a:prstGeom prst="rect">
+            <a:avLst/>
+          </a:prstGeom>
+          <a:noFill/>
+          <a:ln/>
+        </p:spPr>
+        <p:txBody>
+          <a:bodyPr wrap="square" lIns="0" tIns="0" rIns="0" bIns="0" rtlCol="0" anchor="t"/>
+          <a:lstStyle/>
+          <a:p>
+            <a:pPr indent="0" marL="0">
+              <a:lnSpc>
+                <a:spcPct val="95000"/>
+              </a:lnSpc>
               <a:buNone/>
             </a:pPr>
             <a:r>
@@ -7894,8 +7837,8 @@
         </p:nvSpPr>
         <p:spPr>
           <a:xfrm>
-            <a:off x="7360920" y="3307080"/>
-            <a:ext cx="4007815" cy="701040"/>
+            <a:off x="7360920" y="3285236"/>
+            <a:ext cx="4007815" cy="814324"/>
           </a:xfrm>
           <a:prstGeom prst="rect">
             <a:avLst/>
@@ -8120,7 +8063,7 @@
         </p:nvSpPr>
         <p:spPr>
           <a:xfrm>
-            <a:off x="6720840" y="4648200"/>
+            <a:off x="6720840" y="4684776"/>
             <a:ext cx="548640" cy="274320"/>
           </a:xfrm>
           <a:prstGeom prst="rect">
@@ -8160,19 +8103,22 @@
         <p:spPr>
           <a:xfrm>
             <a:off x="7360920" y="4648200"/>
-            <a:ext cx="4007815" cy="365760"/>
-          </a:xfrm>
-          <a:prstGeom prst="rect">
-            <a:avLst/>
-          </a:prstGeom>
-          <a:noFill/>
-          <a:ln/>
-        </p:spPr>
-        <p:txBody>
-          <a:bodyPr wrap="square" lIns="0" tIns="0" rIns="0" bIns="0" rtlCol="0" anchor="t"/>
-          <a:lstStyle/>
-          <a:p>
-            <a:pPr indent="0" marL="0">
+            <a:ext cx="4007815" cy="325628"/>
+          </a:xfrm>
+          <a:prstGeom prst="rect">
+            <a:avLst/>
+          </a:prstGeom>
+          <a:noFill/>
+          <a:ln/>
+        </p:spPr>
+        <p:txBody>
+          <a:bodyPr wrap="square" lIns="0" tIns="0" rIns="0" bIns="0" rtlCol="0" anchor="t"/>
+          <a:lstStyle/>
+          <a:p>
+            <a:pPr indent="0" marL="0">
+              <a:lnSpc>
+                <a:spcPct val="95000"/>
+              </a:lnSpc>
               <a:buNone/>
             </a:pPr>
             <a:r>
@@ -8198,8 +8144,8 @@
         </p:nvSpPr>
         <p:spPr>
           <a:xfrm>
-            <a:off x="7360920" y="5059680"/>
-            <a:ext cx="4007815" cy="701040"/>
+            <a:off x="7360920" y="5037836"/>
+            <a:ext cx="4007815" cy="814324"/>
           </a:xfrm>
           <a:prstGeom prst="rect">
             <a:avLst/>
@@ -8687,23 +8633,23 @@
         <p:spPr>
           <a:xfrm>
             <a:off x="822960" y="2624328"/>
-            <a:ext cx="2600858" cy="365760"/>
-          </a:xfrm>
-          <a:prstGeom prst="rect">
-            <a:avLst/>
-          </a:prstGeom>
-          <a:noFill/>
-          <a:ln/>
-        </p:spPr>
-        <p:txBody>
-          <a:bodyPr wrap="square" lIns="0" tIns="0" rIns="0" bIns="0" rtlCol="0" anchor="t"/>
-          <a:lstStyle/>
-          <a:p>
-            <a:pPr indent="0" marL="0">
-              <a:buNone/>
-            </a:pPr>
-            <a:r>
-              <a:rPr lang="en-US" sz="900" spc="300" kern="0" dirty="0">
+            <a:ext cx="3058058" cy="365760"/>
+          </a:xfrm>
+          <a:prstGeom prst="rect">
+            <a:avLst/>
+          </a:prstGeom>
+          <a:noFill/>
+          <a:ln/>
+        </p:spPr>
+        <p:txBody>
+          <a:bodyPr wrap="square" lIns="0" tIns="0" rIns="0" bIns="0" rtlCol="0" anchor="t"/>
+          <a:lstStyle/>
+          <a:p>
+            <a:pPr indent="0" marL="0">
+              <a:buNone/>
+            </a:pPr>
+            <a:r>
+              <a:rPr lang="en-US" sz="900" spc="200" kern="0" dirty="0">
                 <a:solidFill>
                   <a:srgbClr val="6B6E78"/>
                 </a:solidFill>
@@ -8994,23 +8940,23 @@
         <p:spPr>
           <a:xfrm>
             <a:off x="4612538" y="2624328"/>
-            <a:ext cx="2600858" cy="365760"/>
-          </a:xfrm>
-          <a:prstGeom prst="rect">
-            <a:avLst/>
-          </a:prstGeom>
-          <a:noFill/>
-          <a:ln/>
-        </p:spPr>
-        <p:txBody>
-          <a:bodyPr wrap="square" lIns="0" tIns="0" rIns="0" bIns="0" rtlCol="0" anchor="t"/>
-          <a:lstStyle/>
-          <a:p>
-            <a:pPr indent="0" marL="0">
-              <a:buNone/>
-            </a:pPr>
-            <a:r>
-              <a:rPr lang="en-US" sz="900" spc="300" kern="0" dirty="0">
+            <a:ext cx="3058058" cy="365760"/>
+          </a:xfrm>
+          <a:prstGeom prst="rect">
+            <a:avLst/>
+          </a:prstGeom>
+          <a:noFill/>
+          <a:ln/>
+        </p:spPr>
+        <p:txBody>
+          <a:bodyPr wrap="square" lIns="0" tIns="0" rIns="0" bIns="0" rtlCol="0" anchor="t"/>
+          <a:lstStyle/>
+          <a:p>
+            <a:pPr indent="0" marL="0">
+              <a:buNone/>
+            </a:pPr>
+            <a:r>
+              <a:rPr lang="en-US" sz="900" spc="200" kern="0" dirty="0">
                 <a:solidFill>
                   <a:srgbClr val="6B6E78"/>
                 </a:solidFill>
@@ -9361,7 +9307,7 @@
               <a:buNone/>
             </a:pPr>
             <a:r>
-              <a:rPr lang="en-US" sz="900" spc="300" kern="0" dirty="0">
+              <a:rPr lang="en-US" sz="900" spc="200" kern="0" dirty="0">
                 <a:solidFill>
                   <a:srgbClr val="8B5CF6"/>
                 </a:solidFill>
@@ -9707,7 +9653,7 @@
               <a:buNone/>
             </a:pPr>
             <a:r>
-              <a:rPr lang="en-US" sz="3000" b="1" dirty="0">
+              <a:rPr lang="en-US" sz="3600" b="1" dirty="0">
                 <a:solidFill>
                   <a:srgbClr val="0C0D12"/>
                 </a:solidFill>
@@ -9715,9 +9661,9 @@
                 <a:ea typeface="Space Grotesk" pitchFamily="34" charset="-122"/>
                 <a:cs typeface="Space Grotesk" pitchFamily="34" charset="-120"/>
               </a:rPr>
-              <a:t>The Adoption System: cuatro etapas, cuatro gates.</a:t>
-            </a:r>
-            <a:endParaRPr lang="en-US" sz="3000" dirty="0"/>
+              <a:t>The Adoption System en cuatro etapas.</a:t>
+            </a:r>
+            <a:endParaRPr lang="en-US" sz="3600" dirty="0"/>
           </a:p>
         </p:txBody>
       </p:sp>
@@ -9730,7 +9676,7 @@
         <p:spPr>
           <a:xfrm>
             <a:off x="548640" y="1691640"/>
-            <a:ext cx="9601200" cy="548640"/>
+            <a:ext cx="10607040" cy="548640"/>
           </a:xfrm>
           <a:prstGeom prst="rect">
             <a:avLst/>
@@ -9870,7 +9816,7 @@
               <a:buNone/>
             </a:pPr>
             <a:r>
-              <a:rPr lang="en-US" sz="2400" b="1" dirty="0">
+              <a:rPr lang="en-US" sz="2200" b="1" dirty="0">
                 <a:solidFill>
                   <a:srgbClr val="0C0D12"/>
                 </a:solidFill>
@@ -9880,7 +9826,7 @@
               </a:rPr>
               <a:t>Diagnosticar</a:t>
             </a:r>
-            <a:endParaRPr lang="en-US" sz="2400" dirty="0"/>
+            <a:endParaRPr lang="en-US" sz="2200" dirty="0"/>
           </a:p>
         </p:txBody>
       </p:sp>
@@ -10233,7 +10179,7 @@
               <a:buNone/>
             </a:pPr>
             <a:r>
-              <a:rPr lang="en-US" sz="2400" b="1" dirty="0">
+              <a:rPr lang="en-US" sz="2200" b="1" dirty="0">
                 <a:solidFill>
                   <a:srgbClr val="0C0D12"/>
                 </a:solidFill>
@@ -10243,7 +10189,7 @@
               </a:rPr>
               <a:t>Alinear</a:t>
             </a:r>
-            <a:endParaRPr lang="en-US" sz="2400" dirty="0"/>
+            <a:endParaRPr lang="en-US" sz="2200" dirty="0"/>
           </a:p>
         </p:txBody>
       </p:sp>
@@ -10596,7 +10542,7 @@
               <a:buNone/>
             </a:pPr>
             <a:r>
-              <a:rPr lang="en-US" sz="2400" b="1" dirty="0">
+              <a:rPr lang="en-US" sz="2200" b="1" dirty="0">
                 <a:solidFill>
                   <a:srgbClr val="0C0D12"/>
                 </a:solidFill>
@@ -10606,7 +10552,7 @@
               </a:rPr>
               <a:t>Adoptar</a:t>
             </a:r>
-            <a:endParaRPr lang="en-US" sz="2400" dirty="0"/>
+            <a:endParaRPr lang="en-US" sz="2200" dirty="0"/>
           </a:p>
         </p:txBody>
       </p:sp>
@@ -10959,7 +10905,7 @@
               <a:buNone/>
             </a:pPr>
             <a:r>
-              <a:rPr lang="en-US" sz="2400" b="1" dirty="0">
+              <a:rPr lang="en-US" sz="2200" b="1" dirty="0">
                 <a:solidFill>
                   <a:srgbClr val="0C0D12"/>
                 </a:solidFill>
@@ -10969,7 +10915,7 @@
               </a:rPr>
               <a:t>Sostener</a:t>
             </a:r>
-            <a:endParaRPr lang="en-US" sz="2400" dirty="0"/>
+            <a:endParaRPr lang="en-US" sz="2200" dirty="0"/>
           </a:p>
         </p:txBody>
       </p:sp>
@@ -11534,7 +11480,7 @@
         <p:spPr>
           <a:xfrm>
             <a:off x="548640" y="914400"/>
-            <a:ext cx="5760720" cy="1371600"/>
+            <a:ext cx="5760720" cy="1125728"/>
           </a:xfrm>
           <a:prstGeom prst="rect">
             <a:avLst/>
@@ -11575,8 +11521,8 @@
         </p:nvSpPr>
         <p:spPr>
           <a:xfrm>
-            <a:off x="548640" y="2423160"/>
-            <a:ext cx="5669280" cy="1600200"/>
+            <a:off x="548640" y="2223008"/>
+            <a:ext cx="5669280" cy="1846072"/>
           </a:xfrm>
           <a:prstGeom prst="rect">
             <a:avLst/>

</xml_diff>